<commit_message>
Sjöskolan: numrering vecka för vecka (Övning del.nummer, Inlämning N)
Registret är fältet nummer i placeringarna, med reglerna i innehall/numrering.py
och kontrollen i innehall.py kontrollera. Vecka 40: del 1 frånskiljning, del 2–4
växelström, inlämning 1–7. Samma nummer på webben, i presentationerna, i facit,
i lärarmanus och i QR-granskaren. Övningstexter hänvisar inte längre till nummer.

Co-Authored-By: Claude Opus 5.5 <noreply@anthropic.com>
Claude-Session: https://claude.ai/code/session_011V9KjBb53XrDm23Dw58SH3
</commit_message>
<xml_diff>
--- a/sjoskolan/vecka-37/aktuell/v37_02_Elens_grunder_ombord_elev.pptx
+++ b/sjoskolan/vecka-37/aktuell/v37_02_Elens_grunder_ombord_elev.pptx
@@ -6487,7 +6487,7 @@
                 <a:ea typeface="Calibri"/>
                 <a:cs typeface="Calibri"/>
               </a:rPr>
-              <a:t>E1: Lyser lampan? Följ vägen och motivera.</a:t>
+              <a:t>Övning 1.1: Lyser lampan? Följ vägen och motivera.</a:t>
             </a:r>
           </a:p>
         </p:txBody>
@@ -12571,7 +12571,7 @@
                 <a:ea typeface="Calibri"/>
                 <a:cs typeface="Calibri"/>
               </a:rPr>
-              <a:t>E2: Vad händer med lastströmmen och batteriets spänning?</a:t>
+              <a:t>Övning 1.2: Vad händer med lastströmmen och batteriets spänning?</a:t>
             </a:r>
           </a:p>
         </p:txBody>
@@ -16829,7 +16829,7 @@
                 <a:ea typeface="Calibri"/>
                 <a:cs typeface="Calibri"/>
               </a:rPr>
-              <a:t>E4: Beräkna strömmen. Förklara skillnaden mellan A och B.</a:t>
+              <a:t>Övning 1.4: Beräkna strömmen. Förklara skillnaden mellan A och B.</a:t>
             </a:r>
           </a:p>
         </p:txBody>
@@ -21653,7 +21653,7 @@
                 <a:ea typeface="Calibri"/>
                 <a:cs typeface="Calibri"/>
               </a:rPr>
-              <a:t>E5: Vilken lampa kan fortfarande lysa? Varför?</a:t>
+              <a:t>Övning 1.5: Vilken lampa kan fortfarande lysa? Varför?</a:t>
             </a:r>
           </a:p>
         </p:txBody>
@@ -26876,7 +26876,7 @@
                 <a:ea typeface="Calibri"/>
                 <a:cs typeface="Calibri"/>
               </a:rPr>
-              <a:t>E6: Vad måste klarläggas innan den gemensamma matningen kopplas bort?</a:t>
+              <a:t>Övning 1.6: Vad måste klarläggas innan den gemensamma matningen kopplas bort?</a:t>
             </a:r>
           </a:p>
         </p:txBody>
@@ -27719,7 +27719,7 @@
                 <a:ea typeface="Calibri"/>
                 <a:cs typeface="Calibri"/>
               </a:rPr>
-              <a:t>E7: Beräkna, förklara avbrottet och bedöm vad mätvärdet visar.</a:t>
+              <a:t>Övning 1.7: Beräkna, förklara avbrottet och bedöm vad mätvärdet visar.</a:t>
             </a:r>
           </a:p>
         </p:txBody>

</xml_diff>